<commit_message>
modified docs and src
</commit_message>
<xml_diff>
--- a/docs/IT0206_IBSU_Lunch_Ordering_System_Presentation.pptx
+++ b/docs/IT0206_IBSU_Lunch_Ordering_System_Presentation.pptx
@@ -142,7 +142,7 @@
   <pc:docChgLst>
     <pc:chgData name="Gunther Darius" userId="8d2b46eae991de6c" providerId="LiveId" clId="{A6C91EE9-2DD3-49A5-8165-D560F60A6B62}"/>
     <pc:docChg chg="custSel modSld">
-      <pc:chgData name="Gunther Darius" userId="8d2b46eae991de6c" providerId="LiveId" clId="{A6C91EE9-2DD3-49A5-8165-D560F60A6B62}" dt="2026-09-23T02:47:13.160" v="31" actId="14100"/>
+      <pc:chgData name="Gunther Darius" userId="8d2b46eae991de6c" providerId="LiveId" clId="{A6C91EE9-2DD3-49A5-8165-D560F60A6B62}" dt="2026-09-23T23:10:28.145" v="38" actId="14100"/>
       <pc:docMkLst>
         <pc:docMk/>
       </pc:docMkLst>
@@ -162,13 +162,13 @@
         </pc:spChg>
       </pc:sldChg>
       <pc:sldChg chg="modSp mod">
-        <pc:chgData name="Gunther Darius" userId="8d2b46eae991de6c" providerId="LiveId" clId="{A6C91EE9-2DD3-49A5-8165-D560F60A6B62}" dt="2026-09-23T02:45:38.162" v="25" actId="14100"/>
+        <pc:chgData name="Gunther Darius" userId="8d2b46eae991de6c" providerId="LiveId" clId="{A6C91EE9-2DD3-49A5-8165-D560F60A6B62}" dt="2026-09-23T23:10:28.145" v="38" actId="14100"/>
         <pc:sldMkLst>
           <pc:docMk/>
           <pc:sldMk cId="0" sldId="260"/>
         </pc:sldMkLst>
         <pc:picChg chg="mod">
-          <ac:chgData name="Gunther Darius" userId="8d2b46eae991de6c" providerId="LiveId" clId="{A6C91EE9-2DD3-49A5-8165-D560F60A6B62}" dt="2026-09-23T02:45:38.162" v="25" actId="14100"/>
+          <ac:chgData name="Gunther Darius" userId="8d2b46eae991de6c" providerId="LiveId" clId="{A6C91EE9-2DD3-49A5-8165-D560F60A6B62}" dt="2026-09-23T23:10:28.145" v="38" actId="14100"/>
           <ac:picMkLst>
             <pc:docMk/>
             <pc:sldMk cId="0" sldId="260"/>
@@ -192,13 +192,13 @@
         </pc:picChg>
       </pc:sldChg>
       <pc:sldChg chg="modSp mod">
-        <pc:chgData name="Gunther Darius" userId="8d2b46eae991de6c" providerId="LiveId" clId="{A6C91EE9-2DD3-49A5-8165-D560F60A6B62}" dt="2026-09-23T02:46:22.100" v="27" actId="14100"/>
+        <pc:chgData name="Gunther Darius" userId="8d2b46eae991de6c" providerId="LiveId" clId="{A6C91EE9-2DD3-49A5-8165-D560F60A6B62}" dt="2026-09-23T23:02:28.697" v="33" actId="14100"/>
         <pc:sldMkLst>
           <pc:docMk/>
           <pc:sldMk cId="0" sldId="262"/>
         </pc:sldMkLst>
         <pc:picChg chg="mod">
-          <ac:chgData name="Gunther Darius" userId="8d2b46eae991de6c" providerId="LiveId" clId="{A6C91EE9-2DD3-49A5-8165-D560F60A6B62}" dt="2026-09-23T02:46:22.100" v="27" actId="14100"/>
+          <ac:chgData name="Gunther Darius" userId="8d2b46eae991de6c" providerId="LiveId" clId="{A6C91EE9-2DD3-49A5-8165-D560F60A6B62}" dt="2026-09-23T23:02:28.697" v="33" actId="14100"/>
           <ac:picMkLst>
             <pc:docMk/>
             <pc:sldMk cId="0" sldId="262"/>
@@ -237,13 +237,13 @@
         </pc:picChg>
       </pc:sldChg>
       <pc:sldChg chg="modSp mod">
-        <pc:chgData name="Gunther Darius" userId="8d2b46eae991de6c" providerId="LiveId" clId="{A6C91EE9-2DD3-49A5-8165-D560F60A6B62}" dt="2026-09-23T02:47:07.951" v="30" actId="14100"/>
+        <pc:chgData name="Gunther Darius" userId="8d2b46eae991de6c" providerId="LiveId" clId="{A6C91EE9-2DD3-49A5-8165-D560F60A6B62}" dt="2026-09-23T23:02:34.356" v="34" actId="14100"/>
         <pc:sldMkLst>
           <pc:docMk/>
           <pc:sldMk cId="0" sldId="265"/>
         </pc:sldMkLst>
         <pc:picChg chg="mod">
-          <ac:chgData name="Gunther Darius" userId="8d2b46eae991de6c" providerId="LiveId" clId="{A6C91EE9-2DD3-49A5-8165-D560F60A6B62}" dt="2026-09-23T02:47:07.951" v="30" actId="14100"/>
+          <ac:chgData name="Gunther Darius" userId="8d2b46eae991de6c" providerId="LiveId" clId="{A6C91EE9-2DD3-49A5-8165-D560F60A6B62}" dt="2026-09-23T23:02:34.356" v="34" actId="14100"/>
           <ac:picMkLst>
             <pc:docMk/>
             <pc:sldMk cId="0" sldId="265"/>
@@ -462,7 +462,7 @@
           <a:p>
             <a:fld id="{5BCAD085-E8A6-8845-BD4E-CB4CCA059FC4}" type="datetimeFigureOut">
               <a:rPr lang="en-US" smtClean="0"/>
-              <a:t>9/23/2026</a:t>
+              <a:t>9/24/2026</a:t>
             </a:fld>
             <a:endParaRPr lang="en-US"/>
           </a:p>
@@ -898,7 +898,7 @@
           <a:p>
             <a:fld id="{5BCAD085-E8A6-8845-BD4E-CB4CCA059FC4}" type="datetimeFigureOut">
               <a:rPr lang="en-US" smtClean="0"/>
-              <a:t>9/23/2026</a:t>
+              <a:t>9/24/2026</a:t>
             </a:fld>
             <a:endParaRPr lang="en-US"/>
           </a:p>
@@ -1148,7 +1148,7 @@
           <a:p>
             <a:fld id="{5BCAD085-E8A6-8845-BD4E-CB4CCA059FC4}" type="datetimeFigureOut">
               <a:rPr lang="en-US" smtClean="0"/>
-              <a:t>9/23/2026</a:t>
+              <a:t>9/24/2026</a:t>
             </a:fld>
             <a:endParaRPr lang="en-US"/>
           </a:p>
@@ -1456,7 +1456,7 @@
           <a:p>
             <a:fld id="{5BCAD085-E8A6-8845-BD4E-CB4CCA059FC4}" type="datetimeFigureOut">
               <a:rPr lang="en-US" smtClean="0"/>
-              <a:t>9/23/2026</a:t>
+              <a:t>9/24/2026</a:t>
             </a:fld>
             <a:endParaRPr lang="en-US"/>
           </a:p>
@@ -1774,7 +1774,7 @@
           <a:p>
             <a:fld id="{5BCAD085-E8A6-8845-BD4E-CB4CCA059FC4}" type="datetimeFigureOut">
               <a:rPr lang="en-US" smtClean="0"/>
-              <a:t>9/23/2026</a:t>
+              <a:t>9/24/2026</a:t>
             </a:fld>
             <a:endParaRPr lang="en-US"/>
           </a:p>
@@ -2076,7 +2076,7 @@
           <a:p>
             <a:fld id="{5BCAD085-E8A6-8845-BD4E-CB4CCA059FC4}" type="datetimeFigureOut">
               <a:rPr lang="en-US" smtClean="0"/>
-              <a:t>9/23/2026</a:t>
+              <a:t>9/24/2026</a:t>
             </a:fld>
             <a:endParaRPr lang="en-US"/>
           </a:p>
@@ -2443,7 +2443,7 @@
           <a:p>
             <a:fld id="{5BCAD085-E8A6-8845-BD4E-CB4CCA059FC4}" type="datetimeFigureOut">
               <a:rPr lang="en-US" smtClean="0"/>
-              <a:t>9/23/2026</a:t>
+              <a:t>9/24/2026</a:t>
             </a:fld>
             <a:endParaRPr lang="en-US"/>
           </a:p>
@@ -2617,7 +2617,7 @@
           <a:p>
             <a:fld id="{5BCAD085-E8A6-8845-BD4E-CB4CCA059FC4}" type="datetimeFigureOut">
               <a:rPr lang="en-US" smtClean="0"/>
-              <a:t>9/23/2026</a:t>
+              <a:t>9/24/2026</a:t>
             </a:fld>
             <a:endParaRPr lang="en-US"/>
           </a:p>
@@ -2797,7 +2797,7 @@
           <a:p>
             <a:fld id="{5BCAD085-E8A6-8845-BD4E-CB4CCA059FC4}" type="datetimeFigureOut">
               <a:rPr lang="en-US" smtClean="0"/>
-              <a:t>9/23/2026</a:t>
+              <a:t>9/24/2026</a:t>
             </a:fld>
             <a:endParaRPr lang="en-US"/>
           </a:p>
@@ -2967,7 +2967,7 @@
           <a:p>
             <a:fld id="{5BCAD085-E8A6-8845-BD4E-CB4CCA059FC4}" type="datetimeFigureOut">
               <a:rPr lang="en-US" smtClean="0"/>
-              <a:t>9/23/2026</a:t>
+              <a:t>9/24/2026</a:t>
             </a:fld>
             <a:endParaRPr lang="en-US"/>
           </a:p>
@@ -3217,7 +3217,7 @@
           <a:p>
             <a:fld id="{5BCAD085-E8A6-8845-BD4E-CB4CCA059FC4}" type="datetimeFigureOut">
               <a:rPr lang="en-US" smtClean="0"/>
-              <a:t>9/23/2026</a:t>
+              <a:t>9/24/2026</a:t>
             </a:fld>
             <a:endParaRPr lang="en-US"/>
           </a:p>
@@ -3453,7 +3453,7 @@
           <a:p>
             <a:fld id="{5BCAD085-E8A6-8845-BD4E-CB4CCA059FC4}" type="datetimeFigureOut">
               <a:rPr lang="en-US" smtClean="0"/>
-              <a:t>9/23/2026</a:t>
+              <a:t>9/24/2026</a:t>
             </a:fld>
             <a:endParaRPr lang="en-US"/>
           </a:p>
@@ -3835,7 +3835,7 @@
           <a:p>
             <a:fld id="{5BCAD085-E8A6-8845-BD4E-CB4CCA059FC4}" type="datetimeFigureOut">
               <a:rPr lang="en-US" smtClean="0"/>
-              <a:t>9/23/2026</a:t>
+              <a:t>9/24/2026</a:t>
             </a:fld>
             <a:endParaRPr lang="en-US"/>
           </a:p>
@@ -3953,7 +3953,7 @@
           <a:p>
             <a:fld id="{5BCAD085-E8A6-8845-BD4E-CB4CCA059FC4}" type="datetimeFigureOut">
               <a:rPr lang="en-US" smtClean="0"/>
-              <a:t>9/23/2026</a:t>
+              <a:t>9/24/2026</a:t>
             </a:fld>
             <a:endParaRPr lang="en-US"/>
           </a:p>
@@ -4048,7 +4048,7 @@
           <a:p>
             <a:fld id="{5BCAD085-E8A6-8845-BD4E-CB4CCA059FC4}" type="datetimeFigureOut">
               <a:rPr lang="en-US" smtClean="0"/>
-              <a:t>9/23/2026</a:t>
+              <a:t>9/24/2026</a:t>
             </a:fld>
             <a:endParaRPr lang="en-US"/>
           </a:p>
@@ -4303,7 +4303,7 @@
           <a:p>
             <a:fld id="{5BCAD085-E8A6-8845-BD4E-CB4CCA059FC4}" type="datetimeFigureOut">
               <a:rPr lang="en-US" smtClean="0"/>
-              <a:t>9/23/2026</a:t>
+              <a:t>9/24/2026</a:t>
             </a:fld>
             <a:endParaRPr lang="en-US"/>
           </a:p>
@@ -4586,7 +4586,7 @@
           <a:p>
             <a:fld id="{5BCAD085-E8A6-8845-BD4E-CB4CCA059FC4}" type="datetimeFigureOut">
               <a:rPr lang="en-US" smtClean="0"/>
-              <a:t>9/23/2026</a:t>
+              <a:t>9/24/2026</a:t>
             </a:fld>
             <a:endParaRPr lang="en-US"/>
           </a:p>
@@ -4992,7 +4992,7 @@
           <a:p>
             <a:fld id="{5BCAD085-E8A6-8845-BD4E-CB4CCA059FC4}" type="datetimeFigureOut">
               <a:rPr lang="en-US" smtClean="0"/>
-              <a:t>9/23/2026</a:t>
+              <a:t>9/24/2026</a:t>
             </a:fld>
             <a:endParaRPr lang="en-US"/>
           </a:p>
@@ -5680,8 +5680,8 @@
         </p:blipFill>
         <p:spPr>
           <a:xfrm>
-            <a:off x="6400800" y="1097280"/>
-            <a:ext cx="5212080" cy="2331720"/>
+            <a:off x="6400800" y="1097279"/>
+            <a:ext cx="5212080" cy="2538549"/>
           </a:xfrm>
           <a:prstGeom prst="rect">
             <a:avLst/>
@@ -6857,8 +6857,8 @@
         </p:blipFill>
         <p:spPr>
           <a:xfrm>
-            <a:off x="6400800" y="925287"/>
-            <a:ext cx="5212080" cy="2155370"/>
+            <a:off x="5897880" y="925287"/>
+            <a:ext cx="5715000" cy="2993570"/>
           </a:xfrm>
           <a:prstGeom prst="rect">
             <a:avLst/>
@@ -7152,7 +7152,7 @@
         <p:spPr>
           <a:xfrm>
             <a:off x="6400800" y="1097280"/>
-            <a:ext cx="5212080" cy="2723606"/>
+            <a:ext cx="5212080" cy="3213464"/>
           </a:xfrm>
           <a:prstGeom prst="rect">
             <a:avLst/>

</xml_diff>